<commit_message>
slide #3 updated matrics & Baseline
</commit_message>
<xml_diff>
--- a/Contextual Emotion Classification in Music.pptx
+++ b/Contextual Emotion Classification in Music.pptx
@@ -1,30 +1,34 @@
 
 <file path=ppt/presentation.xml><?xml version="1.0" encoding="utf-8"?>
-<p:presentation xmlns:a="http://schemas.openxmlformats.org/drawingml/2006/main" xmlns:r="http://schemas.openxmlformats.org/officeDocument/2006/relationships" xmlns:p="http://schemas.openxmlformats.org/presentationml/2006/main" embedTrueTypeFonts="1" saveSubsetFonts="1">
+<p:presentation xmlns:a="http://schemas.openxmlformats.org/drawingml/2006/main" xmlns:r="http://schemas.openxmlformats.org/officeDocument/2006/relationships" xmlns:p="http://schemas.openxmlformats.org/presentationml/2006/main" saveSubsetFonts="1" embedTrueTypeFonts="true">
   <p:sldMasterIdLst>
     <p:sldMasterId id="2147483648" r:id="rId1"/>
   </p:sldMasterIdLst>
   <p:sldIdLst>
-    <p:sldId id="256" r:id="rId2"/>
-    <p:sldId id="257" r:id="rId3"/>
-    <p:sldId id="258" r:id="rId4"/>
-    <p:sldId id="259" r:id="rId5"/>
-    <p:sldId id="260" r:id="rId6"/>
+    <p:sldId id="256" r:id="rId6"/>
+    <p:sldId id="257" r:id="rId7"/>
+    <p:sldId id="258" r:id="rId8"/>
+    <p:sldId id="259" r:id="rId9"/>
+    <p:sldId id="260" r:id="rId10"/>
   </p:sldIdLst>
   <p:sldSz cx="18288000" cy="10287000"/>
   <p:notesSz cx="6858000" cy="9144000"/>
   <p:embeddedFontLst>
     <p:embeddedFont>
-      <p:font typeface="Cooper BT Light" panose="020B0604020202020204" charset="0"/>
-      <p:regular r:id="rId7"/>
+      <p:font typeface="Cooper BT Light" charset="1" panose="0208050304030B020404"/>
+      <p:regular r:id="rId11"/>
     </p:embeddedFont>
     <p:embeddedFont>
-      <p:font typeface="Open Sauce" panose="020B0604020202020204" charset="0"/>
-      <p:regular r:id="rId8"/>
+      <p:font typeface="Open Sauce" charset="1" panose="00000500000000000000"/>
+      <p:regular r:id="rId12"/>
     </p:embeddedFont>
     <p:embeddedFont>
-      <p:font typeface="Open Sauce Bold" panose="020B0604020202020204" charset="0"/>
-      <p:regular r:id="rId9"/>
+      <p:font typeface="Arimo" charset="1" panose="020B0604020202020204"/>
+      <p:regular r:id="rId13"/>
+    </p:embeddedFont>
+    <p:embeddedFont>
+      <p:font typeface="Open Sauce Bold" charset="1" panose="00000800000000000000"/>
+      <p:regular r:id="rId14"/>
     </p:embeddedFont>
   </p:embeddedFontLst>
   <p:defaultTextStyle>
@@ -122,22 +126,6 @@
       </a:defRPr>
     </a:lvl9pPr>
   </p:defaultTextStyle>
-  <p:extLst>
-    <p:ext uri="{EFAFB233-063F-42B5-8137-9DF3F51BA10A}">
-      <p15:sldGuideLst xmlns:p15="http://schemas.microsoft.com/office/powerpoint/2012/main">
-        <p15:guide id="1" orient="horz" pos="2160">
-          <p15:clr>
-            <a:srgbClr val="A4A3A4"/>
-          </p15:clr>
-        </p15:guide>
-        <p15:guide id="2" pos="2880">
-          <p15:clr>
-            <a:srgbClr val="A4A3A4"/>
-          </p15:clr>
-        </p15:guide>
-      </p15:sldGuideLst>
-    </p:ext>
-  </p:extLst>
 </p:presentation>
 </file>
 
@@ -179,9 +167,10 @@
           <a:lstStyle/>
           <a:p>
             <a:r>
-              <a:rPr lang="en-US"/>
+              <a:rPr lang="en-US" smtClean="0"/>
               <a:t>Click to edit Master title style</a:t>
             </a:r>
+            <a:endParaRPr lang="en-US"/>
           </a:p>
         </p:txBody>
       </p:sp>
@@ -297,9 +286,10 @@
           </a:lstStyle>
           <a:p>
             <a:r>
-              <a:rPr lang="en-US"/>
+              <a:rPr lang="en-US" smtClean="0"/>
               <a:t>Click to edit Master subtitle style</a:t>
             </a:r>
+            <a:endParaRPr lang="en-US"/>
           </a:p>
         </p:txBody>
       </p:sp>
@@ -321,7 +311,7 @@
             <a:fld id="{1D8BD707-D9CF-40AE-B4C6-C98DA3205C09}" type="datetimeFigureOut">
               <a:rPr lang="en-US" smtClean="0"/>
               <a:pPr/>
-              <a:t>4/1/2025</a:t>
+              <a:t>8/1/2011</a:t>
             </a:fld>
             <a:endParaRPr lang="en-US"/>
           </a:p>
@@ -411,9 +401,10 @@
           <a:lstStyle/>
           <a:p>
             <a:r>
-              <a:rPr lang="en-US"/>
+              <a:rPr lang="en-US" smtClean="0"/>
               <a:t>Click to edit Master title style</a:t>
             </a:r>
+            <a:endParaRPr lang="en-US"/>
           </a:p>
         </p:txBody>
       </p:sp>
@@ -434,37 +425,38 @@
           <a:p>
             <a:pPr lvl="0"/>
             <a:r>
-              <a:rPr lang="en-US"/>
+              <a:rPr lang="en-US" smtClean="0"/>
               <a:t>Click to edit Master text styles</a:t>
             </a:r>
           </a:p>
           <a:p>
             <a:pPr lvl="1"/>
             <a:r>
-              <a:rPr lang="en-US"/>
+              <a:rPr lang="en-US" smtClean="0"/>
               <a:t>Second level</a:t>
             </a:r>
           </a:p>
           <a:p>
             <a:pPr lvl="2"/>
             <a:r>
-              <a:rPr lang="en-US"/>
+              <a:rPr lang="en-US" smtClean="0"/>
               <a:t>Third level</a:t>
             </a:r>
           </a:p>
           <a:p>
             <a:pPr lvl="3"/>
             <a:r>
-              <a:rPr lang="en-US"/>
+              <a:rPr lang="en-US" smtClean="0"/>
               <a:t>Fourth level</a:t>
             </a:r>
           </a:p>
           <a:p>
             <a:pPr lvl="4"/>
             <a:r>
-              <a:rPr lang="en-US"/>
+              <a:rPr lang="en-US" smtClean="0"/>
               <a:t>Fifth level</a:t>
             </a:r>
+            <a:endParaRPr lang="en-US"/>
           </a:p>
         </p:txBody>
       </p:sp>
@@ -486,7 +478,7 @@
             <a:fld id="{1D8BD707-D9CF-40AE-B4C6-C98DA3205C09}" type="datetimeFigureOut">
               <a:rPr lang="en-US" smtClean="0"/>
               <a:pPr/>
-              <a:t>4/1/2025</a:t>
+              <a:t>8/1/2011</a:t>
             </a:fld>
             <a:endParaRPr lang="en-US"/>
           </a:p>
@@ -581,9 +573,10 @@
           <a:lstStyle/>
           <a:p>
             <a:r>
-              <a:rPr lang="en-US"/>
+              <a:rPr lang="en-US" smtClean="0"/>
               <a:t>Click to edit Master title style</a:t>
             </a:r>
+            <a:endParaRPr lang="en-US"/>
           </a:p>
         </p:txBody>
       </p:sp>
@@ -609,37 +602,38 @@
           <a:p>
             <a:pPr lvl="0"/>
             <a:r>
-              <a:rPr lang="en-US"/>
+              <a:rPr lang="en-US" smtClean="0"/>
               <a:t>Click to edit Master text styles</a:t>
             </a:r>
           </a:p>
           <a:p>
             <a:pPr lvl="1"/>
             <a:r>
-              <a:rPr lang="en-US"/>
+              <a:rPr lang="en-US" smtClean="0"/>
               <a:t>Second level</a:t>
             </a:r>
           </a:p>
           <a:p>
             <a:pPr lvl="2"/>
             <a:r>
-              <a:rPr lang="en-US"/>
+              <a:rPr lang="en-US" smtClean="0"/>
               <a:t>Third level</a:t>
             </a:r>
           </a:p>
           <a:p>
             <a:pPr lvl="3"/>
             <a:r>
-              <a:rPr lang="en-US"/>
+              <a:rPr lang="en-US" smtClean="0"/>
               <a:t>Fourth level</a:t>
             </a:r>
           </a:p>
           <a:p>
             <a:pPr lvl="4"/>
             <a:r>
-              <a:rPr lang="en-US"/>
+              <a:rPr lang="en-US" smtClean="0"/>
               <a:t>Fifth level</a:t>
             </a:r>
+            <a:endParaRPr lang="en-US"/>
           </a:p>
         </p:txBody>
       </p:sp>
@@ -661,7 +655,7 @@
             <a:fld id="{1D8BD707-D9CF-40AE-B4C6-C98DA3205C09}" type="datetimeFigureOut">
               <a:rPr lang="en-US" smtClean="0"/>
               <a:pPr/>
-              <a:t>4/1/2025</a:t>
+              <a:t>8/1/2011</a:t>
             </a:fld>
             <a:endParaRPr lang="en-US"/>
           </a:p>
@@ -751,9 +745,10 @@
           <a:lstStyle/>
           <a:p>
             <a:r>
-              <a:rPr lang="en-US"/>
+              <a:rPr lang="en-US" smtClean="0"/>
               <a:t>Click to edit Master title style</a:t>
             </a:r>
+            <a:endParaRPr lang="en-US"/>
           </a:p>
         </p:txBody>
       </p:sp>
@@ -774,37 +769,38 @@
           <a:p>
             <a:pPr lvl="0"/>
             <a:r>
-              <a:rPr lang="en-US"/>
+              <a:rPr lang="en-US" smtClean="0"/>
               <a:t>Click to edit Master text styles</a:t>
             </a:r>
           </a:p>
           <a:p>
             <a:pPr lvl="1"/>
             <a:r>
-              <a:rPr lang="en-US"/>
+              <a:rPr lang="en-US" smtClean="0"/>
               <a:t>Second level</a:t>
             </a:r>
           </a:p>
           <a:p>
             <a:pPr lvl="2"/>
             <a:r>
-              <a:rPr lang="en-US"/>
+              <a:rPr lang="en-US" smtClean="0"/>
               <a:t>Third level</a:t>
             </a:r>
           </a:p>
           <a:p>
             <a:pPr lvl="3"/>
             <a:r>
-              <a:rPr lang="en-US"/>
+              <a:rPr lang="en-US" smtClean="0"/>
               <a:t>Fourth level</a:t>
             </a:r>
           </a:p>
           <a:p>
             <a:pPr lvl="4"/>
             <a:r>
-              <a:rPr lang="en-US"/>
+              <a:rPr lang="en-US" smtClean="0"/>
               <a:t>Fifth level</a:t>
             </a:r>
+            <a:endParaRPr lang="en-US"/>
           </a:p>
         </p:txBody>
       </p:sp>
@@ -826,7 +822,7 @@
             <a:fld id="{1D8BD707-D9CF-40AE-B4C6-C98DA3205C09}" type="datetimeFigureOut">
               <a:rPr lang="en-US" smtClean="0"/>
               <a:pPr/>
-              <a:t>4/1/2025</a:t>
+              <a:t>8/1/2011</a:t>
             </a:fld>
             <a:endParaRPr lang="en-US"/>
           </a:p>
@@ -925,9 +921,10 @@
           </a:lstStyle>
           <a:p>
             <a:r>
-              <a:rPr lang="en-US"/>
+              <a:rPr lang="en-US" smtClean="0"/>
               <a:t>Click to edit Master title style</a:t>
             </a:r>
+            <a:endParaRPr lang="en-US"/>
           </a:p>
         </p:txBody>
       </p:sp>
@@ -1044,7 +1041,7 @@
           <a:p>
             <a:pPr lvl="0"/>
             <a:r>
-              <a:rPr lang="en-US"/>
+              <a:rPr lang="en-US" smtClean="0"/>
               <a:t>Click to edit Master text styles</a:t>
             </a:r>
           </a:p>
@@ -1068,7 +1065,7 @@
             <a:fld id="{1D8BD707-D9CF-40AE-B4C6-C98DA3205C09}" type="datetimeFigureOut">
               <a:rPr lang="en-US" smtClean="0"/>
               <a:pPr/>
-              <a:t>4/1/2025</a:t>
+              <a:t>8/1/2011</a:t>
             </a:fld>
             <a:endParaRPr lang="en-US"/>
           </a:p>
@@ -1158,9 +1155,10 @@
           <a:lstStyle/>
           <a:p>
             <a:r>
-              <a:rPr lang="en-US"/>
+              <a:rPr lang="en-US" smtClean="0"/>
               <a:t>Click to edit Master title style</a:t>
             </a:r>
+            <a:endParaRPr lang="en-US"/>
           </a:p>
         </p:txBody>
       </p:sp>
@@ -1214,37 +1212,38 @@
           <a:p>
             <a:pPr lvl="0"/>
             <a:r>
-              <a:rPr lang="en-US"/>
+              <a:rPr lang="en-US" smtClean="0"/>
               <a:t>Click to edit Master text styles</a:t>
             </a:r>
           </a:p>
           <a:p>
             <a:pPr lvl="1"/>
             <a:r>
-              <a:rPr lang="en-US"/>
+              <a:rPr lang="en-US" smtClean="0"/>
               <a:t>Second level</a:t>
             </a:r>
           </a:p>
           <a:p>
             <a:pPr lvl="2"/>
             <a:r>
-              <a:rPr lang="en-US"/>
+              <a:rPr lang="en-US" smtClean="0"/>
               <a:t>Third level</a:t>
             </a:r>
           </a:p>
           <a:p>
             <a:pPr lvl="3"/>
             <a:r>
-              <a:rPr lang="en-US"/>
+              <a:rPr lang="en-US" smtClean="0"/>
               <a:t>Fourth level</a:t>
             </a:r>
           </a:p>
           <a:p>
             <a:pPr lvl="4"/>
             <a:r>
-              <a:rPr lang="en-US"/>
+              <a:rPr lang="en-US" smtClean="0"/>
               <a:t>Fifth level</a:t>
             </a:r>
+            <a:endParaRPr lang="en-US"/>
           </a:p>
         </p:txBody>
       </p:sp>
@@ -1298,37 +1297,38 @@
           <a:p>
             <a:pPr lvl="0"/>
             <a:r>
-              <a:rPr lang="en-US"/>
+              <a:rPr lang="en-US" smtClean="0"/>
               <a:t>Click to edit Master text styles</a:t>
             </a:r>
           </a:p>
           <a:p>
             <a:pPr lvl="1"/>
             <a:r>
-              <a:rPr lang="en-US"/>
+              <a:rPr lang="en-US" smtClean="0"/>
               <a:t>Second level</a:t>
             </a:r>
           </a:p>
           <a:p>
             <a:pPr lvl="2"/>
             <a:r>
-              <a:rPr lang="en-US"/>
+              <a:rPr lang="en-US" smtClean="0"/>
               <a:t>Third level</a:t>
             </a:r>
           </a:p>
           <a:p>
             <a:pPr lvl="3"/>
             <a:r>
-              <a:rPr lang="en-US"/>
+              <a:rPr lang="en-US" smtClean="0"/>
               <a:t>Fourth level</a:t>
             </a:r>
           </a:p>
           <a:p>
             <a:pPr lvl="4"/>
             <a:r>
-              <a:rPr lang="en-US"/>
+              <a:rPr lang="en-US" smtClean="0"/>
               <a:t>Fifth level</a:t>
             </a:r>
+            <a:endParaRPr lang="en-US"/>
           </a:p>
         </p:txBody>
       </p:sp>
@@ -1350,7 +1350,7 @@
             <a:fld id="{1D8BD707-D9CF-40AE-B4C6-C98DA3205C09}" type="datetimeFigureOut">
               <a:rPr lang="en-US" smtClean="0"/>
               <a:pPr/>
-              <a:t>4/1/2025</a:t>
+              <a:t>8/1/2011</a:t>
             </a:fld>
             <a:endParaRPr lang="en-US"/>
           </a:p>
@@ -1444,9 +1444,10 @@
           </a:lstStyle>
           <a:p>
             <a:r>
-              <a:rPr lang="en-US"/>
+              <a:rPr lang="en-US" smtClean="0"/>
               <a:t>Click to edit Master title style</a:t>
             </a:r>
+            <a:endParaRPr lang="en-US"/>
           </a:p>
         </p:txBody>
       </p:sp>
@@ -1509,7 +1510,7 @@
           <a:p>
             <a:pPr lvl="0"/>
             <a:r>
-              <a:rPr lang="en-US"/>
+              <a:rPr lang="en-US" smtClean="0"/>
               <a:t>Click to edit Master text styles</a:t>
             </a:r>
           </a:p>
@@ -1565,37 +1566,38 @@
           <a:p>
             <a:pPr lvl="0"/>
             <a:r>
-              <a:rPr lang="en-US"/>
+              <a:rPr lang="en-US" smtClean="0"/>
               <a:t>Click to edit Master text styles</a:t>
             </a:r>
           </a:p>
           <a:p>
             <a:pPr lvl="1"/>
             <a:r>
-              <a:rPr lang="en-US"/>
+              <a:rPr lang="en-US" smtClean="0"/>
               <a:t>Second level</a:t>
             </a:r>
           </a:p>
           <a:p>
             <a:pPr lvl="2"/>
             <a:r>
-              <a:rPr lang="en-US"/>
+              <a:rPr lang="en-US" smtClean="0"/>
               <a:t>Third level</a:t>
             </a:r>
           </a:p>
           <a:p>
             <a:pPr lvl="3"/>
             <a:r>
-              <a:rPr lang="en-US"/>
+              <a:rPr lang="en-US" smtClean="0"/>
               <a:t>Fourth level</a:t>
             </a:r>
           </a:p>
           <a:p>
             <a:pPr lvl="4"/>
             <a:r>
-              <a:rPr lang="en-US"/>
+              <a:rPr lang="en-US" smtClean="0"/>
               <a:t>Fifth level</a:t>
             </a:r>
+            <a:endParaRPr lang="en-US"/>
           </a:p>
         </p:txBody>
       </p:sp>
@@ -1658,7 +1660,7 @@
           <a:p>
             <a:pPr lvl="0"/>
             <a:r>
-              <a:rPr lang="en-US"/>
+              <a:rPr lang="en-US" smtClean="0"/>
               <a:t>Click to edit Master text styles</a:t>
             </a:r>
           </a:p>
@@ -1714,37 +1716,38 @@
           <a:p>
             <a:pPr lvl="0"/>
             <a:r>
-              <a:rPr lang="en-US"/>
+              <a:rPr lang="en-US" smtClean="0"/>
               <a:t>Click to edit Master text styles</a:t>
             </a:r>
           </a:p>
           <a:p>
             <a:pPr lvl="1"/>
             <a:r>
-              <a:rPr lang="en-US"/>
+              <a:rPr lang="en-US" smtClean="0"/>
               <a:t>Second level</a:t>
             </a:r>
           </a:p>
           <a:p>
             <a:pPr lvl="2"/>
             <a:r>
-              <a:rPr lang="en-US"/>
+              <a:rPr lang="en-US" smtClean="0"/>
               <a:t>Third level</a:t>
             </a:r>
           </a:p>
           <a:p>
             <a:pPr lvl="3"/>
             <a:r>
-              <a:rPr lang="en-US"/>
+              <a:rPr lang="en-US" smtClean="0"/>
               <a:t>Fourth level</a:t>
             </a:r>
           </a:p>
           <a:p>
             <a:pPr lvl="4"/>
             <a:r>
-              <a:rPr lang="en-US"/>
+              <a:rPr lang="en-US" smtClean="0"/>
               <a:t>Fifth level</a:t>
             </a:r>
+            <a:endParaRPr lang="en-US"/>
           </a:p>
         </p:txBody>
       </p:sp>
@@ -1766,7 +1769,7 @@
             <a:fld id="{1D8BD707-D9CF-40AE-B4C6-C98DA3205C09}" type="datetimeFigureOut">
               <a:rPr lang="en-US" smtClean="0"/>
               <a:pPr/>
-              <a:t>4/1/2025</a:t>
+              <a:t>8/1/2011</a:t>
             </a:fld>
             <a:endParaRPr lang="en-US"/>
           </a:p>
@@ -1856,9 +1859,10 @@
           <a:lstStyle/>
           <a:p>
             <a:r>
-              <a:rPr lang="en-US"/>
+              <a:rPr lang="en-US" smtClean="0"/>
               <a:t>Click to edit Master title style</a:t>
             </a:r>
+            <a:endParaRPr lang="en-US"/>
           </a:p>
         </p:txBody>
       </p:sp>
@@ -1880,7 +1884,7 @@
             <a:fld id="{1D8BD707-D9CF-40AE-B4C6-C98DA3205C09}" type="datetimeFigureOut">
               <a:rPr lang="en-US" smtClean="0"/>
               <a:pPr/>
-              <a:t>4/1/2025</a:t>
+              <a:t>8/1/2011</a:t>
             </a:fld>
             <a:endParaRPr lang="en-US"/>
           </a:p>
@@ -1972,7 +1976,7 @@
             <a:fld id="{1D8BD707-D9CF-40AE-B4C6-C98DA3205C09}" type="datetimeFigureOut">
               <a:rPr lang="en-US" smtClean="0"/>
               <a:pPr/>
-              <a:t>4/1/2025</a:t>
+              <a:t>8/1/2011</a:t>
             </a:fld>
             <a:endParaRPr lang="en-US"/>
           </a:p>
@@ -2071,9 +2075,10 @@
           </a:lstStyle>
           <a:p>
             <a:r>
-              <a:rPr lang="en-US"/>
+              <a:rPr lang="en-US" smtClean="0"/>
               <a:t>Click to edit Master title style</a:t>
             </a:r>
+            <a:endParaRPr lang="en-US"/>
           </a:p>
         </p:txBody>
       </p:sp>
@@ -2127,37 +2132,38 @@
           <a:p>
             <a:pPr lvl="0"/>
             <a:r>
-              <a:rPr lang="en-US"/>
+              <a:rPr lang="en-US" smtClean="0"/>
               <a:t>Click to edit Master text styles</a:t>
             </a:r>
           </a:p>
           <a:p>
             <a:pPr lvl="1"/>
             <a:r>
-              <a:rPr lang="en-US"/>
+              <a:rPr lang="en-US" smtClean="0"/>
               <a:t>Second level</a:t>
             </a:r>
           </a:p>
           <a:p>
             <a:pPr lvl="2"/>
             <a:r>
-              <a:rPr lang="en-US"/>
+              <a:rPr lang="en-US" smtClean="0"/>
               <a:t>Third level</a:t>
             </a:r>
           </a:p>
           <a:p>
             <a:pPr lvl="3"/>
             <a:r>
-              <a:rPr lang="en-US"/>
+              <a:rPr lang="en-US" smtClean="0"/>
               <a:t>Fourth level</a:t>
             </a:r>
           </a:p>
           <a:p>
             <a:pPr lvl="4"/>
             <a:r>
-              <a:rPr lang="en-US"/>
+              <a:rPr lang="en-US" smtClean="0"/>
               <a:t>Fifth level</a:t>
             </a:r>
+            <a:endParaRPr lang="en-US"/>
           </a:p>
         </p:txBody>
       </p:sp>
@@ -2220,7 +2226,7 @@
           <a:p>
             <a:pPr lvl="0"/>
             <a:r>
-              <a:rPr lang="en-US"/>
+              <a:rPr lang="en-US" smtClean="0"/>
               <a:t>Click to edit Master text styles</a:t>
             </a:r>
           </a:p>
@@ -2244,7 +2250,7 @@
             <a:fld id="{1D8BD707-D9CF-40AE-B4C6-C98DA3205C09}" type="datetimeFigureOut">
               <a:rPr lang="en-US" smtClean="0"/>
               <a:pPr/>
-              <a:t>4/1/2025</a:t>
+              <a:t>8/1/2011</a:t>
             </a:fld>
             <a:endParaRPr lang="en-US"/>
           </a:p>
@@ -2343,9 +2349,10 @@
           </a:lstStyle>
           <a:p>
             <a:r>
-              <a:rPr lang="en-US"/>
+              <a:rPr lang="en-US" smtClean="0"/>
               <a:t>Click to edit Master title style</a:t>
             </a:r>
+            <a:endParaRPr lang="en-US"/>
           </a:p>
         </p:txBody>
       </p:sp>
@@ -2469,7 +2476,7 @@
           <a:p>
             <a:pPr lvl="0"/>
             <a:r>
-              <a:rPr lang="en-US"/>
+              <a:rPr lang="en-US" smtClean="0"/>
               <a:t>Click to edit Master text styles</a:t>
             </a:r>
           </a:p>
@@ -2493,7 +2500,7 @@
             <a:fld id="{1D8BD707-D9CF-40AE-B4C6-C98DA3205C09}" type="datetimeFigureOut">
               <a:rPr lang="en-US" smtClean="0"/>
               <a:pPr/>
-              <a:t>4/1/2025</a:t>
+              <a:t>8/1/2011</a:t>
             </a:fld>
             <a:endParaRPr lang="en-US"/>
           </a:p>
@@ -2598,9 +2605,10 @@
           <a:lstStyle/>
           <a:p>
             <a:r>
-              <a:rPr lang="en-US"/>
+              <a:rPr lang="en-US" smtClean="0"/>
               <a:t>Click to edit Master title style</a:t>
             </a:r>
+            <a:endParaRPr lang="en-US"/>
           </a:p>
         </p:txBody>
       </p:sp>
@@ -2631,37 +2639,38 @@
           <a:p>
             <a:pPr lvl="0"/>
             <a:r>
-              <a:rPr lang="en-US"/>
+              <a:rPr lang="en-US" smtClean="0"/>
               <a:t>Click to edit Master text styles</a:t>
             </a:r>
           </a:p>
           <a:p>
             <a:pPr lvl="1"/>
             <a:r>
-              <a:rPr lang="en-US"/>
+              <a:rPr lang="en-US" smtClean="0"/>
               <a:t>Second level</a:t>
             </a:r>
           </a:p>
           <a:p>
             <a:pPr lvl="2"/>
             <a:r>
-              <a:rPr lang="en-US"/>
+              <a:rPr lang="en-US" smtClean="0"/>
               <a:t>Third level</a:t>
             </a:r>
           </a:p>
           <a:p>
             <a:pPr lvl="3"/>
             <a:r>
-              <a:rPr lang="en-US"/>
+              <a:rPr lang="en-US" smtClean="0"/>
               <a:t>Fourth level</a:t>
             </a:r>
           </a:p>
           <a:p>
             <a:pPr lvl="4"/>
             <a:r>
-              <a:rPr lang="en-US"/>
+              <a:rPr lang="en-US" smtClean="0"/>
               <a:t>Fifth level</a:t>
             </a:r>
+            <a:endParaRPr lang="en-US"/>
           </a:p>
         </p:txBody>
       </p:sp>
@@ -2701,7 +2710,7 @@
             <a:fld id="{1D8BD707-D9CF-40AE-B4C6-C98DA3205C09}" type="datetimeFigureOut">
               <a:rPr lang="en-US" smtClean="0"/>
               <a:pPr/>
-              <a:t>4/1/2025</a:t>
+              <a:t>8/1/2011</a:t>
             </a:fld>
             <a:endParaRPr lang="en-US"/>
           </a:p>
@@ -3056,14 +3065,13 @@
 </file>
 
 <file path=ppt/slides/slide1.xml><?xml version="1.0" encoding="utf-8"?>
-<p:sld xmlns:a="http://schemas.openxmlformats.org/drawingml/2006/main" xmlns:r="http://schemas.openxmlformats.org/officeDocument/2006/relationships" xmlns:p="http://schemas.openxmlformats.org/presentationml/2006/main">
+<p:sld xmlns:p="http://schemas.openxmlformats.org/presentationml/2006/main" xmlns:a="http://schemas.openxmlformats.org/drawingml/2006/main" xmlns:r="http://schemas.openxmlformats.org/officeDocument/2006/relationships">
   <p:cSld>
     <p:bg>
       <p:bgPr>
         <a:solidFill>
           <a:srgbClr val="0077B6"/>
         </a:solidFill>
-        <a:effectLst/>
       </p:bgPr>
     </p:bg>
     <p:spTree>
@@ -3082,12 +3090,12 @@
       </p:grpSpPr>
       <p:sp>
         <p:nvSpPr>
-          <p:cNvPr id="2" name="TextBox 2"/>
-          <p:cNvSpPr txBox="1"/>
+          <p:cNvPr name="TextBox 2" id="2"/>
+          <p:cNvSpPr txBox="true"/>
           <p:nvPr/>
         </p:nvSpPr>
         <p:spPr>
-          <a:xfrm>
+          <a:xfrm rot="0">
             <a:off x="1722301" y="3369093"/>
             <a:ext cx="14843398" cy="1974281"/>
           </a:xfrm>
@@ -3096,7 +3104,7 @@
           </a:prstGeom>
         </p:spPr>
         <p:txBody>
-          <a:bodyPr lIns="0" tIns="0" rIns="0" bIns="0" rtlCol="0" anchor="t">
+          <a:bodyPr anchor="t" rtlCol="false" tIns="0" lIns="0" bIns="0" rIns="0">
             <a:spAutoFit/>
           </a:bodyPr>
           <a:lstStyle/>
@@ -3123,12 +3131,12 @@
       </p:sp>
       <p:sp>
         <p:nvSpPr>
-          <p:cNvPr id="3" name="TextBox 3"/>
-          <p:cNvSpPr txBox="1"/>
+          <p:cNvPr name="TextBox 3" id="3"/>
+          <p:cNvSpPr txBox="true"/>
           <p:nvPr/>
         </p:nvSpPr>
         <p:spPr>
-          <a:xfrm>
+          <a:xfrm rot="0">
             <a:off x="1722301" y="6026568"/>
             <a:ext cx="14843398" cy="424180"/>
           </a:xfrm>
@@ -3137,7 +3145,7 @@
           </a:prstGeom>
         </p:spPr>
         <p:txBody>
-          <a:bodyPr lIns="0" tIns="0" rIns="0" bIns="0" rtlCol="0" anchor="t">
+          <a:bodyPr anchor="t" rtlCol="false" tIns="0" lIns="0" bIns="0" rIns="0">
             <a:spAutoFit/>
           </a:bodyPr>
           <a:lstStyle/>
@@ -3164,21 +3172,21 @@
       </p:sp>
       <p:sp>
         <p:nvSpPr>
-          <p:cNvPr id="4" name="TextBox 4"/>
-          <p:cNvSpPr txBox="1"/>
+          <p:cNvPr name="TextBox 4" id="4"/>
+          <p:cNvSpPr txBox="true"/>
           <p:nvPr/>
         </p:nvSpPr>
         <p:spPr>
-          <a:xfrm>
-            <a:off x="609600" y="8174109"/>
-            <a:ext cx="3238500" cy="527196"/>
+          <a:xfrm rot="0">
+            <a:off x="1028700" y="8233099"/>
+            <a:ext cx="2316480" cy="537845"/>
           </a:xfrm>
           <a:prstGeom prst="rect">
             <a:avLst/>
           </a:prstGeom>
         </p:spPr>
         <p:txBody>
-          <a:bodyPr wrap="square" lIns="0" tIns="0" rIns="0" bIns="0" rtlCol="0" anchor="t">
+          <a:bodyPr anchor="t" rtlCol="false" tIns="0" lIns="0" bIns="0" rIns="0">
             <a:spAutoFit/>
           </a:bodyPr>
           <a:lstStyle/>
@@ -3192,7 +3200,7 @@
               </a:spcBef>
             </a:pPr>
             <a:r>
-              <a:rPr lang="en-US" sz="3200" dirty="0">
+              <a:rPr lang="en-US" sz="3200">
                 <a:solidFill>
                   <a:srgbClr val="F1F1EE"/>
                 </a:solidFill>
@@ -3208,21 +3216,21 @@
       </p:sp>
       <p:sp>
         <p:nvSpPr>
-          <p:cNvPr id="5" name="TextBox 5"/>
-          <p:cNvSpPr txBox="1"/>
+          <p:cNvPr name="TextBox 5" id="5"/>
+          <p:cNvSpPr txBox="true"/>
           <p:nvPr/>
         </p:nvSpPr>
         <p:spPr>
-          <a:xfrm>
-            <a:off x="1066800" y="8877300"/>
-            <a:ext cx="9448800" cy="527196"/>
+          <a:xfrm rot="0">
+            <a:off x="1028700" y="8932228"/>
+            <a:ext cx="8115300" cy="566420"/>
           </a:xfrm>
           <a:prstGeom prst="rect">
             <a:avLst/>
           </a:prstGeom>
         </p:spPr>
         <p:txBody>
-          <a:bodyPr wrap="square" lIns="0" tIns="0" rIns="0" bIns="0" rtlCol="0" anchor="t">
+          <a:bodyPr anchor="t" rtlCol="false" tIns="0" lIns="0" bIns="0" rIns="0">
             <a:spAutoFit/>
           </a:bodyPr>
           <a:lstStyle/>
@@ -3233,19 +3241,15 @@
               </a:lnSpc>
             </a:pPr>
             <a:r>
-              <a:rPr lang="en-US" sz="3200" dirty="0">
+              <a:rPr lang="en-US" sz="3200" u="sng">
                 <a:solidFill>
                   <a:srgbClr val="F1F1EE"/>
                 </a:solidFill>
-                <a:latin typeface="Open Sauce"/>
+                <a:latin typeface="Arimo"/>
+                <a:ea typeface="Arimo"/>
+                <a:cs typeface="Arimo"/>
                 <a:sym typeface="Arimo"/>
-                <a:hlinkClick r:id="rId2" tooltip="https://github.com/shaiDahari/EmotionBeat.git">
-                  <a:extLst>
-                    <a:ext uri="{A12FA001-AC4F-418D-AE19-62706E023703}">
-                      <ahyp:hlinkClr xmlns:ahyp="http://schemas.microsoft.com/office/drawing/2018/hyperlinkcolor" val="tx"/>
-                    </a:ext>
-                  </a:extLst>
-                </a:hlinkClick>
+                <a:hlinkClick r:id="rId2" tooltip="https://github.com/shaiDahari/EmotionBeat.git"/>
               </a:rPr>
               <a:t>https://github.com/shaiDahari/EmotionBeat.git</a:t>
             </a:r>
@@ -3261,14 +3265,13 @@
 </file>
 
 <file path=ppt/slides/slide2.xml><?xml version="1.0" encoding="utf-8"?>
-<p:sld xmlns:a="http://schemas.openxmlformats.org/drawingml/2006/main" xmlns:r="http://schemas.openxmlformats.org/officeDocument/2006/relationships" xmlns:p="http://schemas.openxmlformats.org/presentationml/2006/main">
+<p:sld xmlns:p="http://schemas.openxmlformats.org/presentationml/2006/main" xmlns:a="http://schemas.openxmlformats.org/drawingml/2006/main">
   <p:cSld>
     <p:bg>
       <p:bgPr>
         <a:solidFill>
           <a:srgbClr val="F1F1EE"/>
         </a:solidFill>
-        <a:effectLst/>
       </p:bgPr>
     </p:bg>
     <p:spTree>
@@ -3287,7 +3290,7 @@
       </p:grpSpPr>
       <p:grpSp>
         <p:nvGrpSpPr>
-          <p:cNvPr id="2" name="Group 2"/>
+          <p:cNvPr name="Group 2" id="2"/>
           <p:cNvGrpSpPr/>
           <p:nvPr/>
         </p:nvGrpSpPr>
@@ -3301,12 +3304,12 @@
         </p:grpSpPr>
         <p:sp>
           <p:nvSpPr>
-            <p:cNvPr id="3" name="Freeform 3"/>
+            <p:cNvPr name="Freeform 3" id="3"/>
             <p:cNvSpPr/>
             <p:nvPr/>
           </p:nvSpPr>
           <p:spPr>
-            <a:xfrm>
+            <a:xfrm flipH="false" flipV="false" rot="0">
               <a:off x="0" y="0"/>
               <a:ext cx="411795" cy="6186311"/>
             </a:xfrm>
@@ -3315,9 +3318,9 @@
               <a:gdLst/>
               <a:ahLst/>
               <a:cxnLst/>
-              <a:rect l="l" t="t" r="r" b="b"/>
+              <a:rect r="r" b="b" t="t" l="l"/>
               <a:pathLst>
-                <a:path w="411795" h="6186311">
+                <a:path h="6186311" w="411795">
                   <a:moveTo>
                     <a:pt x="0" y="0"/>
                   </a:moveTo>
@@ -3338,23 +3341,16 @@
               <a:srgbClr val="0077B6"/>
             </a:solidFill>
           </p:spPr>
-          <p:txBody>
-            <a:bodyPr/>
-            <a:lstStyle/>
-            <a:p>
-              <a:endParaRPr lang="en-IL"/>
-            </a:p>
-          </p:txBody>
         </p:sp>
       </p:grpSp>
       <p:sp>
         <p:nvSpPr>
-          <p:cNvPr id="4" name="TextBox 4"/>
-          <p:cNvSpPr txBox="1"/>
+          <p:cNvPr name="TextBox 4" id="4"/>
+          <p:cNvSpPr txBox="true"/>
           <p:nvPr/>
         </p:nvSpPr>
         <p:spPr>
-          <a:xfrm>
+          <a:xfrm rot="0">
             <a:off x="3316239" y="1400711"/>
             <a:ext cx="10881914" cy="1368424"/>
           </a:xfrm>
@@ -3363,7 +3359,7 @@
           </a:prstGeom>
         </p:spPr>
         <p:txBody>
-          <a:bodyPr lIns="0" tIns="0" rIns="0" bIns="0" rtlCol="0" anchor="t">
+          <a:bodyPr anchor="t" rtlCol="false" tIns="0" lIns="0" bIns="0" rIns="0">
             <a:spAutoFit/>
           </a:bodyPr>
           <a:lstStyle/>
@@ -3390,12 +3386,12 @@
       </p:sp>
       <p:sp>
         <p:nvSpPr>
-          <p:cNvPr id="5" name="TextBox 5"/>
-          <p:cNvSpPr txBox="1"/>
+          <p:cNvPr name="TextBox 5" id="5"/>
+          <p:cNvSpPr txBox="true"/>
           <p:nvPr/>
         </p:nvSpPr>
         <p:spPr>
-          <a:xfrm>
+          <a:xfrm rot="0">
             <a:off x="8757196" y="196559"/>
             <a:ext cx="773608" cy="738506"/>
           </a:xfrm>
@@ -3404,7 +3400,7 @@
           </a:prstGeom>
         </p:spPr>
         <p:txBody>
-          <a:bodyPr lIns="0" tIns="0" rIns="0" bIns="0" rtlCol="0" anchor="t">
+          <a:bodyPr anchor="t" rtlCol="false" tIns="0" lIns="0" bIns="0" rIns="0">
             <a:spAutoFit/>
           </a:bodyPr>
           <a:lstStyle/>
@@ -3431,12 +3427,12 @@
       </p:sp>
       <p:sp>
         <p:nvSpPr>
-          <p:cNvPr id="6" name="TextBox 6"/>
-          <p:cNvSpPr txBox="1"/>
+          <p:cNvPr name="TextBox 6" id="6"/>
+          <p:cNvSpPr txBox="true"/>
           <p:nvPr/>
         </p:nvSpPr>
         <p:spPr>
-          <a:xfrm>
+          <a:xfrm rot="0">
             <a:off x="398419" y="3311589"/>
             <a:ext cx="6326776" cy="613410"/>
           </a:xfrm>
@@ -3445,7 +3441,7 @@
           </a:prstGeom>
         </p:spPr>
         <p:txBody>
-          <a:bodyPr lIns="0" tIns="0" rIns="0" bIns="0" rtlCol="0" anchor="t">
+          <a:bodyPr anchor="t" rtlCol="false" tIns="0" lIns="0" bIns="0" rIns="0">
             <a:spAutoFit/>
           </a:bodyPr>
           <a:lstStyle/>
@@ -3456,7 +3452,7 @@
               </a:lnSpc>
             </a:pPr>
             <a:r>
-              <a:rPr lang="en-US" sz="3600" b="1">
+              <a:rPr lang="en-US" sz="3600" b="true">
                 <a:solidFill>
                   <a:srgbClr val="0077B6"/>
                 </a:solidFill>
@@ -3472,12 +3468,12 @@
       </p:sp>
       <p:sp>
         <p:nvSpPr>
-          <p:cNvPr id="7" name="TextBox 7"/>
-          <p:cNvSpPr txBox="1"/>
+          <p:cNvPr name="TextBox 7" id="7"/>
+          <p:cNvSpPr txBox="true"/>
           <p:nvPr/>
         </p:nvSpPr>
         <p:spPr>
-          <a:xfrm>
+          <a:xfrm rot="0">
             <a:off x="398419" y="4564380"/>
             <a:ext cx="8442720" cy="4693920"/>
           </a:xfrm>
@@ -3486,12 +3482,12 @@
           </a:prstGeom>
         </p:spPr>
         <p:txBody>
-          <a:bodyPr lIns="0" tIns="0" rIns="0" bIns="0" rtlCol="0" anchor="t">
+          <a:bodyPr anchor="t" rtlCol="false" tIns="0" lIns="0" bIns="0" rIns="0">
             <a:spAutoFit/>
           </a:bodyPr>
           <a:lstStyle/>
           <a:p>
-            <a:pPr marL="604519" lvl="1" indent="-302260" algn="just">
+            <a:pPr algn="just" marL="604519" indent="-302260" lvl="1">
               <a:lnSpc>
                 <a:spcPts val="4199"/>
               </a:lnSpc>
@@ -3512,7 +3508,7 @@
             </a:r>
           </a:p>
           <a:p>
-            <a:pPr marL="604519" lvl="1" indent="-302260" algn="just">
+            <a:pPr algn="just" marL="604519" indent="-302260" lvl="1">
               <a:lnSpc>
                 <a:spcPts val="4199"/>
               </a:lnSpc>
@@ -3533,7 +3529,7 @@
             </a:r>
           </a:p>
           <a:p>
-            <a:pPr marL="604519" lvl="1" indent="-302260" algn="just">
+            <a:pPr algn="just" marL="604519" indent="-302260" lvl="1">
               <a:lnSpc>
                 <a:spcPts val="4199"/>
               </a:lnSpc>
@@ -3554,7 +3550,7 @@
             </a:r>
           </a:p>
           <a:p>
-            <a:pPr marL="604519" lvl="1" indent="-302260" algn="just">
+            <a:pPr algn="just" marL="604519" indent="-302260" lvl="1">
               <a:lnSpc>
                 <a:spcPts val="4199"/>
               </a:lnSpc>
@@ -3580,26 +3576,17 @@
                 <a:spcPts val="4199"/>
               </a:lnSpc>
             </a:pPr>
-            <a:endParaRPr lang="en-US" sz="2799">
-              <a:solidFill>
-                <a:srgbClr val="0077B6"/>
-              </a:solidFill>
-              <a:latin typeface="Open Sauce"/>
-              <a:ea typeface="Open Sauce"/>
-              <a:cs typeface="Open Sauce"/>
-              <a:sym typeface="Open Sauce"/>
-            </a:endParaRPr>
-          </a:p>
-        </p:txBody>
-      </p:sp>
-      <p:sp>
-        <p:nvSpPr>
-          <p:cNvPr id="8" name="TextBox 8"/>
-          <p:cNvSpPr txBox="1"/>
+          </a:p>
+        </p:txBody>
+      </p:sp>
+      <p:sp>
+        <p:nvSpPr>
+          <p:cNvPr name="TextBox 8" id="8"/>
+          <p:cNvSpPr txBox="true"/>
           <p:nvPr/>
         </p:nvSpPr>
         <p:spPr>
-          <a:xfrm>
+          <a:xfrm rot="0">
             <a:off x="9530804" y="3369577"/>
             <a:ext cx="6326776" cy="613410"/>
           </a:xfrm>
@@ -3608,7 +3595,7 @@
           </a:prstGeom>
         </p:spPr>
         <p:txBody>
-          <a:bodyPr lIns="0" tIns="0" rIns="0" bIns="0" rtlCol="0" anchor="t">
+          <a:bodyPr anchor="t" rtlCol="false" tIns="0" lIns="0" bIns="0" rIns="0">
             <a:spAutoFit/>
           </a:bodyPr>
           <a:lstStyle/>
@@ -3619,7 +3606,7 @@
               </a:lnSpc>
             </a:pPr>
             <a:r>
-              <a:rPr lang="en-US" sz="3600" b="1">
+              <a:rPr lang="en-US" sz="3600" b="true">
                 <a:solidFill>
                   <a:srgbClr val="0077B6"/>
                 </a:solidFill>
@@ -3635,12 +3622,12 @@
       </p:sp>
       <p:sp>
         <p:nvSpPr>
-          <p:cNvPr id="9" name="TextBox 9"/>
-          <p:cNvSpPr txBox="1"/>
+          <p:cNvPr name="TextBox 9" id="9"/>
+          <p:cNvSpPr txBox="true"/>
           <p:nvPr/>
         </p:nvSpPr>
         <p:spPr>
-          <a:xfrm>
+          <a:xfrm rot="0">
             <a:off x="9530804" y="4564380"/>
             <a:ext cx="8465167" cy="4693920"/>
           </a:xfrm>
@@ -3649,12 +3636,12 @@
           </a:prstGeom>
         </p:spPr>
         <p:txBody>
-          <a:bodyPr lIns="0" tIns="0" rIns="0" bIns="0" rtlCol="0" anchor="t">
+          <a:bodyPr anchor="t" rtlCol="false" tIns="0" lIns="0" bIns="0" rIns="0">
             <a:spAutoFit/>
           </a:bodyPr>
           <a:lstStyle/>
           <a:p>
-            <a:pPr marL="604519" lvl="1" indent="-302260" algn="just">
+            <a:pPr algn="just" marL="604519" indent="-302260" lvl="1">
               <a:lnSpc>
                 <a:spcPts val="4199"/>
               </a:lnSpc>
@@ -3675,7 +3662,7 @@
             </a:r>
           </a:p>
           <a:p>
-            <a:pPr marL="604519" lvl="1" indent="-302260" algn="just">
+            <a:pPr algn="just" marL="604519" indent="-302260" lvl="1">
               <a:lnSpc>
                 <a:spcPts val="4199"/>
               </a:lnSpc>
@@ -3696,7 +3683,7 @@
             </a:r>
           </a:p>
           <a:p>
-            <a:pPr marL="604519" lvl="1" indent="-302260" algn="just">
+            <a:pPr algn="just" marL="604519" indent="-302260" lvl="1">
               <a:lnSpc>
                 <a:spcPts val="4199"/>
               </a:lnSpc>
@@ -3717,7 +3704,7 @@
             </a:r>
           </a:p>
           <a:p>
-            <a:pPr marL="604519" lvl="1" indent="-302260" algn="just">
+            <a:pPr algn="just" marL="604519" indent="-302260" lvl="1">
               <a:lnSpc>
                 <a:spcPts val="4199"/>
               </a:lnSpc>
@@ -3743,15 +3730,6 @@
                 <a:spcPts val="4199"/>
               </a:lnSpc>
             </a:pPr>
-            <a:endParaRPr lang="en-US" sz="2799">
-              <a:solidFill>
-                <a:srgbClr val="0077B6"/>
-              </a:solidFill>
-              <a:latin typeface="Open Sauce"/>
-              <a:ea typeface="Open Sauce"/>
-              <a:cs typeface="Open Sauce"/>
-              <a:sym typeface="Open Sauce"/>
-            </a:endParaRPr>
           </a:p>
         </p:txBody>
       </p:sp>
@@ -3764,14 +3742,13 @@
 </file>
 
 <file path=ppt/slides/slide3.xml><?xml version="1.0" encoding="utf-8"?>
-<p:sld xmlns:a="http://schemas.openxmlformats.org/drawingml/2006/main" xmlns:r="http://schemas.openxmlformats.org/officeDocument/2006/relationships" xmlns:p="http://schemas.openxmlformats.org/presentationml/2006/main">
+<p:sld xmlns:p="http://schemas.openxmlformats.org/presentationml/2006/main" xmlns:a="http://schemas.openxmlformats.org/drawingml/2006/main">
   <p:cSld>
     <p:bg>
       <p:bgPr>
         <a:solidFill>
           <a:srgbClr val="F1F1EE"/>
         </a:solidFill>
-        <a:effectLst/>
       </p:bgPr>
     </p:bg>
     <p:spTree>
@@ -3790,7 +3767,7 @@
       </p:grpSpPr>
       <p:grpSp>
         <p:nvGrpSpPr>
-          <p:cNvPr id="2" name="Group 2"/>
+          <p:cNvPr name="Group 2" id="2"/>
           <p:cNvGrpSpPr/>
           <p:nvPr/>
         </p:nvGrpSpPr>
@@ -3804,12 +3781,12 @@
         </p:grpSpPr>
         <p:sp>
           <p:nvSpPr>
-            <p:cNvPr id="3" name="Freeform 3"/>
+            <p:cNvPr name="Freeform 3" id="3"/>
             <p:cNvSpPr/>
             <p:nvPr/>
           </p:nvSpPr>
           <p:spPr>
-            <a:xfrm>
+            <a:xfrm flipH="false" flipV="false" rot="0">
               <a:off x="0" y="0"/>
               <a:ext cx="411795" cy="6186311"/>
             </a:xfrm>
@@ -3818,9 +3795,9 @@
               <a:gdLst/>
               <a:ahLst/>
               <a:cxnLst/>
-              <a:rect l="l" t="t" r="r" b="b"/>
+              <a:rect r="r" b="b" t="t" l="l"/>
               <a:pathLst>
-                <a:path w="411795" h="6186311">
+                <a:path h="6186311" w="411795">
                   <a:moveTo>
                     <a:pt x="0" y="0"/>
                   </a:moveTo>
@@ -3841,23 +3818,16 @@
               <a:srgbClr val="0077B6"/>
             </a:solidFill>
           </p:spPr>
-          <p:txBody>
-            <a:bodyPr/>
-            <a:lstStyle/>
-            <a:p>
-              <a:endParaRPr lang="en-IL"/>
-            </a:p>
-          </p:txBody>
         </p:sp>
       </p:grpSp>
       <p:sp>
         <p:nvSpPr>
-          <p:cNvPr id="4" name="TextBox 4"/>
-          <p:cNvSpPr txBox="1"/>
+          <p:cNvPr name="TextBox 4" id="4"/>
+          <p:cNvSpPr txBox="true"/>
           <p:nvPr/>
         </p:nvSpPr>
         <p:spPr>
-          <a:xfrm>
+          <a:xfrm rot="0">
             <a:off x="3489198" y="1658669"/>
             <a:ext cx="11309604" cy="1368424"/>
           </a:xfrm>
@@ -3866,7 +3836,7 @@
           </a:prstGeom>
         </p:spPr>
         <p:txBody>
-          <a:bodyPr lIns="0" tIns="0" rIns="0" bIns="0" rtlCol="0" anchor="t">
+          <a:bodyPr anchor="t" rtlCol="false" tIns="0" lIns="0" bIns="0" rIns="0">
             <a:spAutoFit/>
           </a:bodyPr>
           <a:lstStyle/>
@@ -3893,12 +3863,12 @@
       </p:sp>
       <p:sp>
         <p:nvSpPr>
-          <p:cNvPr id="5" name="TextBox 5"/>
-          <p:cNvSpPr txBox="1"/>
+          <p:cNvPr name="TextBox 5" id="5"/>
+          <p:cNvSpPr txBox="true"/>
           <p:nvPr/>
         </p:nvSpPr>
         <p:spPr>
-          <a:xfrm>
+          <a:xfrm rot="0">
             <a:off x="8757196" y="247359"/>
             <a:ext cx="773608" cy="646431"/>
           </a:xfrm>
@@ -3907,7 +3877,7 @@
           </a:prstGeom>
         </p:spPr>
         <p:txBody>
-          <a:bodyPr lIns="0" tIns="0" rIns="0" bIns="0" rtlCol="0" anchor="t">
+          <a:bodyPr anchor="t" rtlCol="false" tIns="0" lIns="0" bIns="0" rIns="0">
             <a:spAutoFit/>
           </a:bodyPr>
           <a:lstStyle/>
@@ -3934,12 +3904,12 @@
       </p:sp>
       <p:sp>
         <p:nvSpPr>
-          <p:cNvPr id="6" name="TextBox 6"/>
-          <p:cNvSpPr txBox="1"/>
+          <p:cNvPr name="TextBox 6" id="6"/>
+          <p:cNvSpPr txBox="true"/>
           <p:nvPr/>
         </p:nvSpPr>
         <p:spPr>
-          <a:xfrm>
+          <a:xfrm rot="0">
             <a:off x="1028700" y="3544614"/>
             <a:ext cx="9695136" cy="1313180"/>
           </a:xfrm>
@@ -3948,7 +3918,7 @@
           </a:prstGeom>
         </p:spPr>
         <p:txBody>
-          <a:bodyPr lIns="0" tIns="0" rIns="0" bIns="0" rtlCol="0" anchor="t">
+          <a:bodyPr anchor="t" rtlCol="false" tIns="0" lIns="0" bIns="0" rIns="0">
             <a:spAutoFit/>
           </a:bodyPr>
           <a:lstStyle/>
@@ -3959,7 +3929,7 @@
               </a:lnSpc>
             </a:pPr>
             <a:r>
-              <a:rPr lang="en-US" sz="3799" b="1">
+              <a:rPr lang="en-US" sz="3799" b="true">
                 <a:solidFill>
                   <a:srgbClr val="0077B6"/>
                 </a:solidFill>
@@ -3977,26 +3947,17 @@
                 <a:spcPts val="5319"/>
               </a:lnSpc>
             </a:pPr>
-            <a:endParaRPr lang="en-US" sz="3799" b="1">
-              <a:solidFill>
-                <a:srgbClr val="0077B6"/>
-              </a:solidFill>
-              <a:latin typeface="Open Sauce Bold"/>
-              <a:ea typeface="Open Sauce Bold"/>
-              <a:cs typeface="Open Sauce Bold"/>
-              <a:sym typeface="Open Sauce Bold"/>
-            </a:endParaRPr>
-          </a:p>
-        </p:txBody>
-      </p:sp>
-      <p:sp>
-        <p:nvSpPr>
-          <p:cNvPr id="7" name="TextBox 7"/>
-          <p:cNvSpPr txBox="1"/>
+          </a:p>
+        </p:txBody>
+      </p:sp>
+      <p:sp>
+        <p:nvSpPr>
+          <p:cNvPr name="TextBox 7" id="7"/>
+          <p:cNvSpPr txBox="true"/>
           <p:nvPr/>
         </p:nvSpPr>
         <p:spPr>
-          <a:xfrm>
+          <a:xfrm rot="0">
             <a:off x="1028700" y="4325302"/>
             <a:ext cx="13440148" cy="1550670"/>
           </a:xfrm>
@@ -4005,12 +3966,12 @@
           </a:prstGeom>
         </p:spPr>
         <p:txBody>
-          <a:bodyPr lIns="0" tIns="0" rIns="0" bIns="0" rtlCol="0" anchor="t">
+          <a:bodyPr anchor="t" rtlCol="false" tIns="0" lIns="0" bIns="0" rIns="0">
             <a:spAutoFit/>
           </a:bodyPr>
           <a:lstStyle/>
           <a:p>
-            <a:pPr marL="604519" lvl="1" indent="-302260" algn="just">
+            <a:pPr algn="just" marL="604519" indent="-302260" lvl="1">
               <a:lnSpc>
                 <a:spcPts val="4199"/>
               </a:lnSpc>
@@ -4027,11 +3988,23 @@
                 <a:cs typeface="Open Sauce"/>
                 <a:sym typeface="Open Sauce"/>
               </a:rPr>
-              <a:t>Kaggle dataset containing 160K+ tracks with metadata</a:t>
-            </a:r>
-          </a:p>
-          <a:p>
-            <a:pPr marL="604519" lvl="1" indent="-302260" algn="just">
+              <a:t>Kaggl</a:t>
+            </a:r>
+            <a:r>
+              <a:rPr lang="en-US" sz="2799">
+                <a:solidFill>
+                  <a:srgbClr val="0077B6"/>
+                </a:solidFill>
+                <a:latin typeface="Open Sauce"/>
+                <a:ea typeface="Open Sauce"/>
+                <a:cs typeface="Open Sauce"/>
+                <a:sym typeface="Open Sauce"/>
+              </a:rPr>
+              <a:t>e dataset containing 160K+ tracks with metadata</a:t>
+            </a:r>
+          </a:p>
+          <a:p>
+            <a:pPr algn="just" marL="604519" indent="-302260" lvl="1">
               <a:lnSpc>
                 <a:spcPts val="4199"/>
               </a:lnSpc>
@@ -4057,26 +4030,17 @@
                 <a:spcPts val="4199"/>
               </a:lnSpc>
             </a:pPr>
-            <a:endParaRPr lang="en-US" sz="2799">
-              <a:solidFill>
-                <a:srgbClr val="0077B6"/>
-              </a:solidFill>
-              <a:latin typeface="Open Sauce"/>
-              <a:ea typeface="Open Sauce"/>
-              <a:cs typeface="Open Sauce"/>
-              <a:sym typeface="Open Sauce"/>
-            </a:endParaRPr>
-          </a:p>
-        </p:txBody>
-      </p:sp>
-      <p:sp>
-        <p:nvSpPr>
-          <p:cNvPr id="8" name="TextBox 8"/>
-          <p:cNvSpPr txBox="1"/>
+          </a:p>
+        </p:txBody>
+      </p:sp>
+      <p:sp>
+        <p:nvSpPr>
+          <p:cNvPr name="TextBox 8" id="8"/>
+          <p:cNvSpPr txBox="true"/>
           <p:nvPr/>
         </p:nvSpPr>
         <p:spPr>
-          <a:xfrm>
+          <a:xfrm rot="0">
             <a:off x="1028700" y="6038850"/>
             <a:ext cx="3545891" cy="646430"/>
           </a:xfrm>
@@ -4085,7 +4049,7 @@
           </a:prstGeom>
         </p:spPr>
         <p:txBody>
-          <a:bodyPr lIns="0" tIns="0" rIns="0" bIns="0" rtlCol="0" anchor="t">
+          <a:bodyPr anchor="t" rtlCol="false" tIns="0" lIns="0" bIns="0" rIns="0">
             <a:spAutoFit/>
           </a:bodyPr>
           <a:lstStyle/>
@@ -4096,7 +4060,7 @@
               </a:lnSpc>
             </a:pPr>
             <a:r>
-              <a:rPr lang="en-US" sz="3799" b="1">
+              <a:rPr lang="en-US" sz="3799" b="true">
                 <a:solidFill>
                   <a:srgbClr val="0077B6"/>
                 </a:solidFill>
@@ -4112,12 +4076,12 @@
       </p:sp>
       <p:sp>
         <p:nvSpPr>
-          <p:cNvPr id="9" name="TextBox 9"/>
-          <p:cNvSpPr txBox="1"/>
+          <p:cNvPr name="TextBox 9" id="9"/>
+          <p:cNvSpPr txBox="true"/>
           <p:nvPr/>
         </p:nvSpPr>
         <p:spPr>
-          <a:xfrm>
+          <a:xfrm rot="0">
             <a:off x="1028700" y="6799983"/>
             <a:ext cx="19533973" cy="1550670"/>
           </a:xfrm>
@@ -4126,12 +4090,12 @@
           </a:prstGeom>
         </p:spPr>
         <p:txBody>
-          <a:bodyPr lIns="0" tIns="0" rIns="0" bIns="0" rtlCol="0" anchor="t">
+          <a:bodyPr anchor="t" rtlCol="false" tIns="0" lIns="0" bIns="0" rIns="0">
             <a:spAutoFit/>
           </a:bodyPr>
           <a:lstStyle/>
           <a:p>
-            <a:pPr marL="604519" lvl="1" indent="-302260" algn="just">
+            <a:pPr algn="just" marL="604519" indent="-302260" lvl="1">
               <a:lnSpc>
                 <a:spcPts val="4199"/>
               </a:lnSpc>
@@ -4148,11 +4112,23 @@
                 <a:cs typeface="Open Sauce"/>
                 <a:sym typeface="Open Sauce"/>
               </a:rPr>
-              <a:t>Source: Partial lyrics and song descriptions where available</a:t>
-            </a:r>
-          </a:p>
-          <a:p>
-            <a:pPr marL="604519" lvl="1" indent="-302260" algn="just">
+              <a:t>S</a:t>
+            </a:r>
+            <a:r>
+              <a:rPr lang="en-US" sz="2799">
+                <a:solidFill>
+                  <a:srgbClr val="0077B6"/>
+                </a:solidFill>
+                <a:latin typeface="Open Sauce"/>
+                <a:ea typeface="Open Sauce"/>
+                <a:cs typeface="Open Sauce"/>
+                <a:sym typeface="Open Sauce"/>
+              </a:rPr>
+              <a:t>ource: Partial lyrics and song descriptions where available</a:t>
+            </a:r>
+          </a:p>
+          <a:p>
+            <a:pPr algn="just" marL="604519" indent="-302260" lvl="1">
               <a:lnSpc>
                 <a:spcPts val="4199"/>
               </a:lnSpc>
@@ -4178,26 +4154,17 @@
                 <a:spcPts val="4199"/>
               </a:lnSpc>
             </a:pPr>
-            <a:endParaRPr lang="en-US" sz="2799">
-              <a:solidFill>
-                <a:srgbClr val="0077B6"/>
-              </a:solidFill>
-              <a:latin typeface="Open Sauce"/>
-              <a:ea typeface="Open Sauce"/>
-              <a:cs typeface="Open Sauce"/>
-              <a:sym typeface="Open Sauce"/>
-            </a:endParaRPr>
-          </a:p>
-        </p:txBody>
-      </p:sp>
-      <p:sp>
-        <p:nvSpPr>
-          <p:cNvPr id="10" name="TextBox 10"/>
-          <p:cNvSpPr txBox="1"/>
+          </a:p>
+        </p:txBody>
+      </p:sp>
+      <p:sp>
+        <p:nvSpPr>
+          <p:cNvPr name="TextBox 10" id="10"/>
+          <p:cNvSpPr txBox="true"/>
           <p:nvPr/>
         </p:nvSpPr>
         <p:spPr>
-          <a:xfrm>
+          <a:xfrm rot="0">
             <a:off x="1620723" y="7856855"/>
             <a:ext cx="12645535" cy="1550670"/>
           </a:xfrm>
@@ -4206,12 +4173,12 @@
           </a:prstGeom>
         </p:spPr>
         <p:txBody>
-          <a:bodyPr lIns="0" tIns="0" rIns="0" bIns="0" rtlCol="0" anchor="t">
+          <a:bodyPr anchor="t" rtlCol="false" tIns="0" lIns="0" bIns="0" rIns="0">
             <a:spAutoFit/>
           </a:bodyPr>
           <a:lstStyle/>
           <a:p>
-            <a:pPr marL="604519" lvl="1" indent="-302260" algn="just">
+            <a:pPr algn="just" marL="604519" indent="-302260" lvl="1">
               <a:lnSpc>
                 <a:spcPts val="4199"/>
               </a:lnSpc>
@@ -4222,7 +4189,7 @@
               <a:buChar char="•"/>
             </a:pPr>
             <a:r>
-              <a:rPr lang="en-US" sz="2799" u="none" strike="noStrike">
+              <a:rPr lang="en-US" sz="2799" strike="noStrike" u="none">
                 <a:solidFill>
                   <a:srgbClr val="0077B6"/>
                 </a:solidFill>
@@ -4235,7 +4202,7 @@
             </a:r>
           </a:p>
           <a:p>
-            <a:pPr marL="604519" lvl="1" indent="-302260" algn="just">
+            <a:pPr algn="just" marL="604519" indent="-302260" lvl="1">
               <a:lnSpc>
                 <a:spcPts val="4199"/>
               </a:lnSpc>
@@ -4246,7 +4213,7 @@
               <a:buChar char="•"/>
             </a:pPr>
             <a:r>
-              <a:rPr lang="en-US" sz="2799" u="none" strike="noStrike">
+              <a:rPr lang="en-US" sz="2799" strike="noStrike" u="none">
                 <a:solidFill>
                   <a:srgbClr val="0077B6"/>
                 </a:solidFill>
@@ -4259,7 +4226,7 @@
             </a:r>
           </a:p>
           <a:p>
-            <a:pPr marL="604519" lvl="1" indent="-302260" algn="just">
+            <a:pPr algn="just" marL="604519" indent="-302260" lvl="1">
               <a:lnSpc>
                 <a:spcPts val="4199"/>
               </a:lnSpc>
@@ -4270,7 +4237,7 @@
               <a:buChar char="•"/>
             </a:pPr>
             <a:r>
-              <a:rPr lang="en-US" sz="2799" u="none" strike="noStrike">
+              <a:rPr lang="en-US" sz="2799" strike="noStrike" u="none">
                 <a:solidFill>
                   <a:srgbClr val="0077B6"/>
                 </a:solidFill>
@@ -4293,14 +4260,13 @@
 </file>
 
 <file path=ppt/slides/slide4.xml><?xml version="1.0" encoding="utf-8"?>
-<p:sld xmlns:a="http://schemas.openxmlformats.org/drawingml/2006/main" xmlns:r="http://schemas.openxmlformats.org/officeDocument/2006/relationships" xmlns:p="http://schemas.openxmlformats.org/presentationml/2006/main">
+<p:sld xmlns:p="http://schemas.openxmlformats.org/presentationml/2006/main" xmlns:a="http://schemas.openxmlformats.org/drawingml/2006/main">
   <p:cSld>
     <p:bg>
       <p:bgPr>
         <a:solidFill>
           <a:srgbClr val="F1F1EE"/>
         </a:solidFill>
-        <a:effectLst/>
       </p:bgPr>
     </p:bg>
     <p:spTree>
@@ -4319,7 +4285,7 @@
       </p:grpSpPr>
       <p:grpSp>
         <p:nvGrpSpPr>
-          <p:cNvPr id="2" name="Group 2"/>
+          <p:cNvPr name="Group 2" id="2"/>
           <p:cNvGrpSpPr/>
           <p:nvPr/>
         </p:nvGrpSpPr>
@@ -4333,12 +4299,12 @@
         </p:grpSpPr>
         <p:sp>
           <p:nvSpPr>
-            <p:cNvPr id="3" name="Freeform 3"/>
+            <p:cNvPr name="Freeform 3" id="3"/>
             <p:cNvSpPr/>
             <p:nvPr/>
           </p:nvSpPr>
           <p:spPr>
-            <a:xfrm>
+            <a:xfrm flipH="false" flipV="false" rot="0">
               <a:off x="0" y="0"/>
               <a:ext cx="411795" cy="6186311"/>
             </a:xfrm>
@@ -4347,9 +4313,9 @@
               <a:gdLst/>
               <a:ahLst/>
               <a:cxnLst/>
-              <a:rect l="l" t="t" r="r" b="b"/>
+              <a:rect r="r" b="b" t="t" l="l"/>
               <a:pathLst>
-                <a:path w="411795" h="6186311">
+                <a:path h="6186311" w="411795">
                   <a:moveTo>
                     <a:pt x="0" y="0"/>
                   </a:moveTo>
@@ -4370,23 +4336,16 @@
               <a:srgbClr val="0077B6"/>
             </a:solidFill>
           </p:spPr>
-          <p:txBody>
-            <a:bodyPr/>
-            <a:lstStyle/>
-            <a:p>
-              <a:endParaRPr lang="en-IL"/>
-            </a:p>
-          </p:txBody>
         </p:sp>
       </p:grpSp>
       <p:sp>
         <p:nvSpPr>
-          <p:cNvPr id="4" name="TextBox 4"/>
-          <p:cNvSpPr txBox="1"/>
+          <p:cNvPr name="TextBox 4" id="4"/>
+          <p:cNvSpPr txBox="true"/>
           <p:nvPr/>
         </p:nvSpPr>
         <p:spPr>
-          <a:xfrm>
+          <a:xfrm rot="0">
             <a:off x="6123197" y="1496890"/>
             <a:ext cx="6041606" cy="1368424"/>
           </a:xfrm>
@@ -4395,7 +4354,7 @@
           </a:prstGeom>
         </p:spPr>
         <p:txBody>
-          <a:bodyPr lIns="0" tIns="0" rIns="0" bIns="0" rtlCol="0" anchor="t">
+          <a:bodyPr anchor="t" rtlCol="false" tIns="0" lIns="0" bIns="0" rIns="0">
             <a:spAutoFit/>
           </a:bodyPr>
           <a:lstStyle/>
@@ -4422,12 +4381,12 @@
       </p:sp>
       <p:sp>
         <p:nvSpPr>
-          <p:cNvPr id="5" name="TextBox 5"/>
-          <p:cNvSpPr txBox="1"/>
+          <p:cNvPr name="TextBox 5" id="5"/>
+          <p:cNvSpPr txBox="true"/>
           <p:nvPr/>
         </p:nvSpPr>
         <p:spPr>
-          <a:xfrm>
+          <a:xfrm rot="0">
             <a:off x="8757196" y="247359"/>
             <a:ext cx="773608" cy="646431"/>
           </a:xfrm>
@@ -4436,7 +4395,7 @@
           </a:prstGeom>
         </p:spPr>
         <p:txBody>
-          <a:bodyPr lIns="0" tIns="0" rIns="0" bIns="0" rtlCol="0" anchor="t">
+          <a:bodyPr anchor="t" rtlCol="false" tIns="0" lIns="0" bIns="0" rIns="0">
             <a:spAutoFit/>
           </a:bodyPr>
           <a:lstStyle/>
@@ -4463,12 +4422,12 @@
       </p:sp>
       <p:sp>
         <p:nvSpPr>
-          <p:cNvPr id="6" name="TextBox 6"/>
-          <p:cNvSpPr txBox="1"/>
+          <p:cNvPr name="TextBox 6" id="6"/>
+          <p:cNvSpPr txBox="true"/>
           <p:nvPr/>
         </p:nvSpPr>
         <p:spPr>
-          <a:xfrm>
+          <a:xfrm rot="0">
             <a:off x="1028700" y="3544614"/>
             <a:ext cx="9695136" cy="646430"/>
           </a:xfrm>
@@ -4477,7 +4436,7 @@
           </a:prstGeom>
         </p:spPr>
         <p:txBody>
-          <a:bodyPr lIns="0" tIns="0" rIns="0" bIns="0" rtlCol="0" anchor="t">
+          <a:bodyPr anchor="t" rtlCol="false" tIns="0" lIns="0" bIns="0" rIns="0">
             <a:spAutoFit/>
           </a:bodyPr>
           <a:lstStyle/>
@@ -4488,7 +4447,7 @@
               </a:lnSpc>
             </a:pPr>
             <a:r>
-              <a:rPr lang="en-US" sz="3799" b="1">
+              <a:rPr lang="en-US" sz="3799" b="true">
                 <a:solidFill>
                   <a:srgbClr val="0077B6"/>
                 </a:solidFill>
@@ -4504,21 +4463,21 @@
       </p:sp>
       <p:sp>
         <p:nvSpPr>
-          <p:cNvPr id="7" name="TextBox 7"/>
-          <p:cNvSpPr txBox="1"/>
+          <p:cNvPr name="TextBox 7" id="7"/>
+          <p:cNvSpPr txBox="true"/>
           <p:nvPr/>
         </p:nvSpPr>
         <p:spPr>
-          <a:xfrm>
+          <a:xfrm rot="0">
             <a:off x="1028700" y="4533945"/>
-            <a:ext cx="13440148" cy="3718560"/>
+            <a:ext cx="7044625" cy="5290185"/>
           </a:xfrm>
           <a:prstGeom prst="rect">
             <a:avLst/>
           </a:prstGeom>
         </p:spPr>
         <p:txBody>
-          <a:bodyPr lIns="0" tIns="0" rIns="0" bIns="0" rtlCol="0" anchor="t">
+          <a:bodyPr anchor="t" rtlCol="false" tIns="0" lIns="0" bIns="0" rIns="0">
             <a:spAutoFit/>
           </a:bodyPr>
           <a:lstStyle/>
@@ -4529,7 +4488,7 @@
               </a:lnSpc>
             </a:pPr>
             <a:r>
-              <a:rPr lang="en-US" sz="2999" b="1">
+              <a:rPr lang="en-US" b="true" sz="2999">
                 <a:solidFill>
                   <a:srgbClr val="0077B6"/>
                 </a:solidFill>
@@ -4538,11 +4497,23 @@
                 <a:cs typeface="Open Sauce Bold"/>
                 <a:sym typeface="Open Sauce Bold"/>
               </a:rPr>
-              <a:t>Classification metrics</a:t>
-            </a:r>
-          </a:p>
-          <a:p>
-            <a:pPr marL="604519" lvl="1" indent="-302260" algn="just">
+              <a:t>Cl</a:t>
+            </a:r>
+            <a:r>
+              <a:rPr lang="en-US" b="true" sz="2999">
+                <a:solidFill>
+                  <a:srgbClr val="0077B6"/>
+                </a:solidFill>
+                <a:latin typeface="Open Sauce Bold"/>
+                <a:ea typeface="Open Sauce Bold"/>
+                <a:cs typeface="Open Sauce Bold"/>
+                <a:sym typeface="Open Sauce Bold"/>
+              </a:rPr>
+              <a:t>assification metrics</a:t>
+            </a:r>
+          </a:p>
+          <a:p>
+            <a:pPr algn="just" marL="604519" indent="-302260" lvl="1">
               <a:lnSpc>
                 <a:spcPts val="4199"/>
               </a:lnSpc>
@@ -4559,11 +4530,11 @@
                 <a:cs typeface="Open Sauce"/>
                 <a:sym typeface="Open Sauce"/>
               </a:rPr>
-              <a:t>Precision and Recall</a:t>
-            </a:r>
-          </a:p>
-          <a:p>
-            <a:pPr marL="604519" lvl="1" indent="-302260" algn="just">
+              <a:t>Precision and Recall.</a:t>
+            </a:r>
+          </a:p>
+          <a:p>
+            <a:pPr algn="just" marL="604519" indent="-302260" lvl="1">
               <a:lnSpc>
                 <a:spcPts val="4199"/>
               </a:lnSpc>
@@ -4580,7 +4551,19 @@
                 <a:cs typeface="Open Sauce"/>
                 <a:sym typeface="Open Sauce"/>
               </a:rPr>
-              <a:t>F1 Score across emotion categories</a:t>
+              <a:t>P</a:t>
+            </a:r>
+            <a:r>
+              <a:rPr lang="en-US" sz="2799">
+                <a:solidFill>
+                  <a:srgbClr val="0077B6"/>
+                </a:solidFill>
+                <a:latin typeface="Open Sauce"/>
+                <a:ea typeface="Open Sauce"/>
+                <a:cs typeface="Open Sauce"/>
+                <a:sym typeface="Open Sauce"/>
+              </a:rPr>
+              <a:t>recision@K.</a:t>
             </a:r>
           </a:p>
           <a:p>
@@ -4590,7 +4573,7 @@
               </a:lnSpc>
             </a:pPr>
             <a:r>
-              <a:rPr lang="en-US" sz="2999" b="1">
+              <a:rPr lang="en-US" b="true" sz="2999">
                 <a:solidFill>
                   <a:srgbClr val="0077B6"/>
                 </a:solidFill>
@@ -4603,7 +4586,7 @@
             </a:r>
           </a:p>
           <a:p>
-            <a:pPr marL="604519" lvl="1" indent="-302260" algn="just">
+            <a:pPr algn="just" marL="604519" indent="-302260" lvl="1">
               <a:lnSpc>
                 <a:spcPts val="4199"/>
               </a:lnSpc>
@@ -4620,28 +4603,7 @@
                 <a:cs typeface="Open Sauce"/>
                 <a:sym typeface="Open Sauce"/>
               </a:rPr>
-              <a:t>TF-IDF + Logistic Regression classifier</a:t>
-            </a:r>
-          </a:p>
-          <a:p>
-            <a:pPr marL="604519" lvl="1" indent="-302260" algn="just">
-              <a:lnSpc>
-                <a:spcPts val="4199"/>
-              </a:lnSpc>
-              <a:buFont typeface="Arial"/>
-              <a:buChar char="•"/>
-            </a:pPr>
-            <a:r>
-              <a:rPr lang="en-US" sz="2799">
-                <a:solidFill>
-                  <a:srgbClr val="0077B6"/>
-                </a:solidFill>
-                <a:latin typeface="Open Sauce"/>
-                <a:ea typeface="Open Sauce"/>
-                <a:cs typeface="Open Sauce"/>
-                <a:sym typeface="Open Sauce"/>
-              </a:rPr>
-              <a:t>Simple embedding similarity</a:t>
+              <a:t>Rank predefined emotion / context labels by computing cosine similarity between their embeddings &amp; the embedding of the song metadata.</a:t>
             </a:r>
           </a:p>
           <a:p>
@@ -4650,26 +4612,24 @@
                 <a:spcPts val="4199"/>
               </a:lnSpc>
             </a:pPr>
-            <a:endParaRPr lang="en-US" sz="2799">
-              <a:solidFill>
-                <a:srgbClr val="0077B6"/>
-              </a:solidFill>
-              <a:latin typeface="Open Sauce"/>
-              <a:ea typeface="Open Sauce"/>
-              <a:cs typeface="Open Sauce"/>
-              <a:sym typeface="Open Sauce"/>
-            </a:endParaRPr>
-          </a:p>
-        </p:txBody>
-      </p:sp>
-      <p:sp>
-        <p:nvSpPr>
-          <p:cNvPr id="8" name="TextBox 8"/>
-          <p:cNvSpPr txBox="1"/>
+          </a:p>
+          <a:p>
+            <a:pPr algn="just">
+              <a:lnSpc>
+                <a:spcPts val="4199"/>
+              </a:lnSpc>
+            </a:pPr>
+          </a:p>
+        </p:txBody>
+      </p:sp>
+      <p:sp>
+        <p:nvSpPr>
+          <p:cNvPr name="TextBox 8" id="8"/>
+          <p:cNvSpPr txBox="true"/>
           <p:nvPr/>
         </p:nvSpPr>
         <p:spPr>
-          <a:xfrm>
+          <a:xfrm rot="0">
             <a:off x="8757196" y="3541589"/>
             <a:ext cx="4938044" cy="646430"/>
           </a:xfrm>
@@ -4678,7 +4638,7 @@
           </a:prstGeom>
         </p:spPr>
         <p:txBody>
-          <a:bodyPr lIns="0" tIns="0" rIns="0" bIns="0" rtlCol="0" anchor="t">
+          <a:bodyPr anchor="t" rtlCol="false" tIns="0" lIns="0" bIns="0" rIns="0">
             <a:spAutoFit/>
           </a:bodyPr>
           <a:lstStyle/>
@@ -4689,7 +4649,7 @@
               </a:lnSpc>
             </a:pPr>
             <a:r>
-              <a:rPr lang="en-US" sz="3799" b="1">
+              <a:rPr lang="en-US" sz="3799" b="true">
                 <a:solidFill>
                   <a:srgbClr val="0077B6"/>
                 </a:solidFill>
@@ -4705,21 +4665,21 @@
       </p:sp>
       <p:sp>
         <p:nvSpPr>
-          <p:cNvPr id="9" name="TextBox 9"/>
-          <p:cNvSpPr txBox="1"/>
+          <p:cNvPr name="TextBox 9" id="9"/>
+          <p:cNvSpPr txBox="true"/>
           <p:nvPr/>
         </p:nvSpPr>
         <p:spPr>
-          <a:xfrm>
+          <a:xfrm rot="0">
             <a:off x="8757196" y="4533945"/>
-            <a:ext cx="9111825" cy="3718560"/>
+            <a:ext cx="9111825" cy="4242435"/>
           </a:xfrm>
           <a:prstGeom prst="rect">
             <a:avLst/>
           </a:prstGeom>
         </p:spPr>
         <p:txBody>
-          <a:bodyPr lIns="0" tIns="0" rIns="0" bIns="0" rtlCol="0" anchor="t">
+          <a:bodyPr anchor="t" rtlCol="false" tIns="0" lIns="0" bIns="0" rIns="0">
             <a:spAutoFit/>
           </a:bodyPr>
           <a:lstStyle/>
@@ -4730,7 +4690,7 @@
               </a:lnSpc>
             </a:pPr>
             <a:r>
-              <a:rPr lang="en-US" sz="2999" b="1">
+              <a:rPr lang="en-US" b="true" sz="2999">
                 <a:solidFill>
                   <a:srgbClr val="0077B6"/>
                 </a:solidFill>
@@ -4739,11 +4699,23 @@
                 <a:cs typeface="Open Sauce Bold"/>
                 <a:sym typeface="Open Sauce Bold"/>
               </a:rPr>
-              <a:t>Text Generation metrics</a:t>
-            </a:r>
-          </a:p>
-          <a:p>
-            <a:pPr marL="604519" lvl="1" indent="-302260" algn="just">
+              <a:t>Text Generati</a:t>
+            </a:r>
+            <a:r>
+              <a:rPr lang="en-US" b="true" sz="2999">
+                <a:solidFill>
+                  <a:srgbClr val="0077B6"/>
+                </a:solidFill>
+                <a:latin typeface="Open Sauce Bold"/>
+                <a:ea typeface="Open Sauce Bold"/>
+                <a:cs typeface="Open Sauce Bold"/>
+                <a:sym typeface="Open Sauce Bold"/>
+              </a:rPr>
+              <a:t>on metrics</a:t>
+            </a:r>
+          </a:p>
+          <a:p>
+            <a:pPr algn="just" marL="604519" indent="-302260" lvl="1">
               <a:lnSpc>
                 <a:spcPts val="4199"/>
               </a:lnSpc>
@@ -4764,7 +4736,7 @@
             </a:r>
           </a:p>
           <a:p>
-            <a:pPr marL="604519" lvl="1" indent="-302260" algn="just">
+            <a:pPr algn="just" marL="604519" indent="-302260" lvl="1">
               <a:lnSpc>
                 <a:spcPts val="4199"/>
               </a:lnSpc>
@@ -4791,7 +4763,7 @@
               </a:lnSpc>
             </a:pPr>
             <a:r>
-              <a:rPr lang="en-US" sz="2999" b="1">
+              <a:rPr lang="en-US" b="true" sz="2999">
                 <a:solidFill>
                   <a:srgbClr val="0077B6"/>
                 </a:solidFill>
@@ -4804,7 +4776,7 @@
             </a:r>
           </a:p>
           <a:p>
-            <a:pPr marL="604519" lvl="1" indent="-302260" algn="just">
+            <a:pPr algn="just" marL="604519" indent="-302260" lvl="1">
               <a:lnSpc>
                 <a:spcPts val="4199"/>
               </a:lnSpc>
@@ -4821,17 +4793,8 @@
                 <a:cs typeface="Open Sauce"/>
                 <a:sym typeface="Open Sauce"/>
               </a:rPr>
-              <a:t>Zero-shot prompting for emotion classification</a:t>
-            </a:r>
-          </a:p>
-          <a:p>
-            <a:pPr marL="604519" lvl="1" indent="-302260" algn="just">
-              <a:lnSpc>
-                <a:spcPts val="4199"/>
-              </a:lnSpc>
-              <a:buFont typeface="Arial"/>
-              <a:buChar char="•"/>
-            </a:pPr>
+              <a:t>Gen</a:t>
+            </a:r>
             <a:r>
               <a:rPr lang="en-US" sz="2799">
                 <a:solidFill>
@@ -4842,7 +4805,7 @@
                 <a:cs typeface="Open Sauce"/>
                 <a:sym typeface="Open Sauce"/>
               </a:rPr>
-              <a:t>Comparison to existing genre categorization</a:t>
+              <a:t>erate free-text emotional descriptions using a simple zero-shot prompt, without examples or task-specific tuning.</a:t>
             </a:r>
           </a:p>
           <a:p>
@@ -4851,15 +4814,6 @@
                 <a:spcPts val="4199"/>
               </a:lnSpc>
             </a:pPr>
-            <a:endParaRPr lang="en-US" sz="2799">
-              <a:solidFill>
-                <a:srgbClr val="0077B6"/>
-              </a:solidFill>
-              <a:latin typeface="Open Sauce"/>
-              <a:ea typeface="Open Sauce"/>
-              <a:cs typeface="Open Sauce"/>
-              <a:sym typeface="Open Sauce"/>
-            </a:endParaRPr>
           </a:p>
         </p:txBody>
       </p:sp>
@@ -4872,14 +4826,13 @@
 </file>
 
 <file path=ppt/slides/slide5.xml><?xml version="1.0" encoding="utf-8"?>
-<p:sld xmlns:a="http://schemas.openxmlformats.org/drawingml/2006/main" xmlns:r="http://schemas.openxmlformats.org/officeDocument/2006/relationships" xmlns:p="http://schemas.openxmlformats.org/presentationml/2006/main">
+<p:sld xmlns:p="http://schemas.openxmlformats.org/presentationml/2006/main" xmlns:a="http://schemas.openxmlformats.org/drawingml/2006/main">
   <p:cSld>
     <p:bg>
       <p:bgPr>
         <a:solidFill>
           <a:srgbClr val="0077B6"/>
         </a:solidFill>
-        <a:effectLst/>
       </p:bgPr>
     </p:bg>
     <p:spTree>
@@ -4898,21 +4851,21 @@
       </p:grpSpPr>
       <p:sp>
         <p:nvSpPr>
-          <p:cNvPr id="2" name="TextBox 2"/>
-          <p:cNvSpPr txBox="1"/>
+          <p:cNvPr name="TextBox 2" id="2"/>
+          <p:cNvSpPr txBox="true"/>
           <p:nvPr/>
         </p:nvSpPr>
         <p:spPr>
-          <a:xfrm>
-            <a:off x="1722301" y="3569118"/>
-            <a:ext cx="14843398" cy="2400300"/>
+          <a:xfrm rot="0">
+            <a:off x="1722301" y="3559593"/>
+            <a:ext cx="14843398" cy="2409825"/>
           </a:xfrm>
           <a:prstGeom prst="rect">
             <a:avLst/>
           </a:prstGeom>
         </p:spPr>
         <p:txBody>
-          <a:bodyPr lIns="0" tIns="0" rIns="0" bIns="0" rtlCol="0" anchor="t">
+          <a:bodyPr anchor="t" rtlCol="false" tIns="0" lIns="0" bIns="0" rIns="0">
             <a:spAutoFit/>
           </a:bodyPr>
           <a:lstStyle/>
@@ -4939,12 +4892,12 @@
       </p:sp>
       <p:sp>
         <p:nvSpPr>
-          <p:cNvPr id="3" name="TextBox 3"/>
-          <p:cNvSpPr txBox="1"/>
+          <p:cNvPr name="TextBox 3" id="3"/>
+          <p:cNvSpPr txBox="true"/>
           <p:nvPr/>
         </p:nvSpPr>
         <p:spPr>
-          <a:xfrm>
+          <a:xfrm rot="0">
             <a:off x="1722301" y="6036093"/>
             <a:ext cx="14843398" cy="481965"/>
           </a:xfrm>
@@ -4953,7 +4906,7 @@
           </a:prstGeom>
         </p:spPr>
         <p:txBody>
-          <a:bodyPr lIns="0" tIns="0" rIns="0" bIns="0" rtlCol="0" anchor="t">
+          <a:bodyPr anchor="t" rtlCol="false" tIns="0" lIns="0" bIns="0" rIns="0">
             <a:spAutoFit/>
           </a:bodyPr>
           <a:lstStyle/>
@@ -4980,12 +4933,12 @@
       </p:sp>
       <p:sp>
         <p:nvSpPr>
-          <p:cNvPr id="4" name="TextBox 4"/>
-          <p:cNvSpPr txBox="1"/>
+          <p:cNvPr name="TextBox 4" id="4"/>
+          <p:cNvSpPr txBox="true"/>
           <p:nvPr/>
         </p:nvSpPr>
         <p:spPr>
-          <a:xfrm>
+          <a:xfrm rot="0">
             <a:off x="914400" y="9201150"/>
             <a:ext cx="11555257" cy="537845"/>
           </a:xfrm>
@@ -4994,7 +4947,7 @@
           </a:prstGeom>
         </p:spPr>
         <p:txBody>
-          <a:bodyPr lIns="0" tIns="0" rIns="0" bIns="0" rtlCol="0" anchor="t">
+          <a:bodyPr anchor="t" rtlCol="false" tIns="0" lIns="0" bIns="0" rIns="0">
             <a:spAutoFit/>
           </a:bodyPr>
           <a:lstStyle/>
@@ -5021,12 +4974,12 @@
       </p:sp>
       <p:sp>
         <p:nvSpPr>
-          <p:cNvPr id="5" name="TextBox 5"/>
-          <p:cNvSpPr txBox="1"/>
+          <p:cNvPr name="TextBox 5" id="5"/>
+          <p:cNvSpPr txBox="true"/>
           <p:nvPr/>
         </p:nvSpPr>
         <p:spPr>
-          <a:xfrm>
+          <a:xfrm rot="0">
             <a:off x="11345517" y="9201150"/>
             <a:ext cx="5913783" cy="537845"/>
           </a:xfrm>
@@ -5035,7 +4988,7 @@
           </a:prstGeom>
         </p:spPr>
         <p:txBody>
-          <a:bodyPr lIns="0" tIns="0" rIns="0" bIns="0" rtlCol="0" anchor="t">
+          <a:bodyPr anchor="t" rtlCol="false" tIns="0" lIns="0" bIns="0" rIns="0">
             <a:spAutoFit/>
           </a:bodyPr>
           <a:lstStyle/>
@@ -5062,12 +5015,12 @@
       </p:sp>
       <p:sp>
         <p:nvSpPr>
-          <p:cNvPr id="6" name="TextBox 6"/>
-          <p:cNvSpPr txBox="1"/>
+          <p:cNvPr name="TextBox 6" id="6"/>
+          <p:cNvSpPr txBox="true"/>
           <p:nvPr/>
         </p:nvSpPr>
         <p:spPr>
-          <a:xfrm>
+          <a:xfrm rot="0">
             <a:off x="914400" y="8574380"/>
             <a:ext cx="3253740" cy="537845"/>
           </a:xfrm>
@@ -5076,7 +5029,7 @@
           </a:prstGeom>
         </p:spPr>
         <p:txBody>
-          <a:bodyPr lIns="0" tIns="0" rIns="0" bIns="0" rtlCol="0" anchor="t">
+          <a:bodyPr anchor="t" rtlCol="false" tIns="0" lIns="0" bIns="0" rIns="0">
             <a:spAutoFit/>
           </a:bodyPr>
           <a:lstStyle/>

</xml_diff>